<commit_message>
docs: add prototype and architecture images across all 5 slides matching template format
</commit_message>
<xml_diff>
--- a/SIH2026-IDEA-Presentation_APAAR-Vault.pptx
+++ b/SIH2026-IDEA-Presentation_APAAR-Vault.pptx
@@ -3826,61 +3826,30 @@
           </a:p>
         </p:txBody>
       </p:sp>
-      <p:sp>
-        <p:nvSpPr>
-          <p:cNvPr id="9" name="Oval 8"/>
-          <p:cNvSpPr/>
-          <p:nvPr/>
-        </p:nvSpPr>
-        <p:spPr>
-          <a:xfrm>
-            <a:off x="4396000" y="1150000"/>
-            <a:ext cx="3400000" cy="4900000"/>
-          </a:xfrm>
-          <a:prstGeom prst="ellipse">
-            <a:avLst/>
-          </a:prstGeom>
-          <a:solidFill>
-            <a:srgbClr val="FFF8F0"/>
-          </a:solidFill>
-          <a:ln w="31750">
-            <a:solidFill>
-              <a:srgbClr val="E65100"/>
-            </a:solidFill>
-          </a:ln>
-        </p:spPr>
-        <p:style>
-          <a:lnRef idx="1">
-            <a:schemeClr val="accent1"/>
-          </a:lnRef>
-          <a:fillRef idx="3">
-            <a:schemeClr val="accent1"/>
-          </a:fillRef>
-          <a:effectRef idx="2">
-            <a:schemeClr val="accent1"/>
-          </a:effectRef>
-          <a:fontRef idx="minor">
-            <a:schemeClr val="lt1"/>
-          </a:fontRef>
-        </p:style>
-        <p:txBody>
-          <a:bodyPr rtlCol="0" anchor="ctr" wrap="square"/>
-          <a:lstStyle/>
-          <a:p>
-            <a:pPr algn="ctr">
-              <a:defRPr b="1" sz="1400">
-                <a:solidFill>
-                  <a:srgbClr val="102A4D"/>
-                </a:solidFill>
-                <a:latin typeface="Calibri"/>
-              </a:defRPr>
-            </a:pPr>
-            <a:r>
-              <a:t>A smart and unique centralized platform to automate student data management, 10-point validation, multi-institution duplicate detection, and intake compliance monitoring for AICTE.</a:t>
-            </a:r>
-          </a:p>
-        </p:txBody>
-      </p:sp>
+      <p:pic>
+        <p:nvPicPr>
+          <p:cNvPr id="9" name="Picture 8" descr="prototype_hub_architecture.png"/>
+          <p:cNvPicPr>
+            <a:picLocks noChangeAspect="1"/>
+          </p:cNvPicPr>
+          <p:nvPr/>
+        </p:nvPicPr>
+        <p:blipFill>
+          <a:blip r:embed="rId3"/>
+          <a:stretch>
+            <a:fillRect/>
+          </a:stretch>
+        </p:blipFill>
+        <p:spPr>
+          <a:xfrm>
+            <a:off x="4250000" y="1150000"/>
+            <a:ext cx="3700000" cy="4950000"/>
+          </a:xfrm>
+          <a:prstGeom prst="rect">
+            <a:avLst/>
+          </a:prstGeom>
+        </p:spPr>
+      </p:pic>
       <p:sp>
         <p:nvSpPr>
           <p:cNvPr id="10" name="Rounded Rectangle 9"/>
@@ -6889,173 +6858,14 @@
         </p:nvSpPr>
         <p:spPr>
           <a:xfrm>
-            <a:off x="550000" y="1200000"/>
-            <a:ext cx="3500000" cy="550000"/>
+            <a:off x="550000" y="1150000"/>
+            <a:ext cx="5100000" cy="1550000"/>
           </a:xfrm>
           <a:prstGeom prst="roundRect">
             <a:avLst/>
           </a:prstGeom>
           <a:solidFill>
-            <a:srgbClr val="E55039"/>
-          </a:solidFill>
-          <a:ln>
-            <a:noFill/>
-          </a:ln>
-        </p:spPr>
-        <p:style>
-          <a:lnRef idx="1">
-            <a:schemeClr val="accent1"/>
-          </a:lnRef>
-          <a:fillRef idx="3">
-            <a:schemeClr val="accent1"/>
-          </a:fillRef>
-          <a:effectRef idx="2">
-            <a:schemeClr val="accent1"/>
-          </a:effectRef>
-          <a:fontRef idx="minor">
-            <a:schemeClr val="lt1"/>
-          </a:fontRef>
-        </p:style>
-        <p:txBody>
-          <a:bodyPr rtlCol="0" anchor="ctr"/>
-          <a:lstStyle/>
-          <a:p>
-            <a:pPr algn="ctr">
-              <a:defRPr b="1" sz="1400">
-                <a:solidFill>
-                  <a:srgbClr val="FFFFFF"/>
-                </a:solidFill>
-                <a:latin typeface="Calibri"/>
-              </a:defRPr>
-            </a:pPr>
-            <a:r>
-              <a:t>Feasibility Analysis</a:t>
-            </a:r>
-          </a:p>
-        </p:txBody>
-      </p:sp>
-      <p:sp>
-        <p:nvSpPr>
-          <p:cNvPr id="10" name="Rounded Rectangle 9"/>
-          <p:cNvSpPr/>
-          <p:nvPr/>
-        </p:nvSpPr>
-        <p:spPr>
-          <a:xfrm>
-            <a:off x="4350000" y="1200000"/>
-            <a:ext cx="3500000" cy="550000"/>
-          </a:xfrm>
-          <a:prstGeom prst="roundRect">
-            <a:avLst/>
-          </a:prstGeom>
-          <a:solidFill>
-            <a:srgbClr val="F39C12"/>
-          </a:solidFill>
-          <a:ln>
-            <a:noFill/>
-          </a:ln>
-        </p:spPr>
-        <p:style>
-          <a:lnRef idx="1">
-            <a:schemeClr val="accent1"/>
-          </a:lnRef>
-          <a:fillRef idx="3">
-            <a:schemeClr val="accent1"/>
-          </a:fillRef>
-          <a:effectRef idx="2">
-            <a:schemeClr val="accent1"/>
-          </a:effectRef>
-          <a:fontRef idx="minor">
-            <a:schemeClr val="lt1"/>
-          </a:fontRef>
-        </p:style>
-        <p:txBody>
-          <a:bodyPr rtlCol="0" anchor="ctr"/>
-          <a:lstStyle/>
-          <a:p>
-            <a:pPr algn="ctr">
-              <a:defRPr b="1" sz="1400">
-                <a:solidFill>
-                  <a:srgbClr val="FFFFFF"/>
-                </a:solidFill>
-                <a:latin typeface="Calibri"/>
-              </a:defRPr>
-            </a:pPr>
-            <a:r>
-              <a:t>Challenges &amp; Risks</a:t>
-            </a:r>
-          </a:p>
-        </p:txBody>
-      </p:sp>
-      <p:sp>
-        <p:nvSpPr>
-          <p:cNvPr id="11" name="Rounded Rectangle 10"/>
-          <p:cNvSpPr/>
-          <p:nvPr/>
-        </p:nvSpPr>
-        <p:spPr>
-          <a:xfrm>
-            <a:off x="8150000" y="1200000"/>
-            <a:ext cx="3500000" cy="550000"/>
-          </a:xfrm>
-          <a:prstGeom prst="roundRect">
-            <a:avLst/>
-          </a:prstGeom>
-          <a:solidFill>
-            <a:srgbClr val="2980B9"/>
-          </a:solidFill>
-          <a:ln>
-            <a:noFill/>
-          </a:ln>
-        </p:spPr>
-        <p:style>
-          <a:lnRef idx="1">
-            <a:schemeClr val="accent1"/>
-          </a:lnRef>
-          <a:fillRef idx="3">
-            <a:schemeClr val="accent1"/>
-          </a:fillRef>
-          <a:effectRef idx="2">
-            <a:schemeClr val="accent1"/>
-          </a:effectRef>
-          <a:fontRef idx="minor">
-            <a:schemeClr val="lt1"/>
-          </a:fontRef>
-        </p:style>
-        <p:txBody>
-          <a:bodyPr rtlCol="0" anchor="ctr"/>
-          <a:lstStyle/>
-          <a:p>
-            <a:pPr algn="ctr">
-              <a:defRPr b="1" sz="1400">
-                <a:solidFill>
-                  <a:srgbClr val="FFFFFF"/>
-                </a:solidFill>
-                <a:latin typeface="Calibri"/>
-              </a:defRPr>
-            </a:pPr>
-            <a:r>
-              <a:t>Mitigation Strategies</a:t>
-            </a:r>
-          </a:p>
-        </p:txBody>
-      </p:sp>
-      <p:sp>
-        <p:nvSpPr>
-          <p:cNvPr id="12" name="Rounded Rectangle 11"/>
-          <p:cNvSpPr/>
-          <p:nvPr/>
-        </p:nvSpPr>
-        <p:spPr>
-          <a:xfrm>
-            <a:off x="550000" y="1900000"/>
-            <a:ext cx="3500000" cy="1300000"/>
-          </a:xfrm>
-          <a:prstGeom prst="roundRect">
-            <a:avLst/>
-          </a:prstGeom>
-          <a:solidFill>
-            <a:srgbClr val="FFF3F0"/>
+            <a:srgbClr val="FFF8F0"/>
           </a:solidFill>
           <a:ln w="19050">
             <a:solidFill>
@@ -7083,186 +6893,106 @@
           <a:p>
             <a:pPr algn="ctr">
               <a:spcAft>
-                <a:spcPts val="400"/>
+                <a:spcPts val="300"/>
               </a:spcAft>
-              <a:defRPr b="1" sz="1300">
+              <a:defRPr b="1" sz="1250">
+                <a:solidFill>
+                  <a:srgbClr val="E55039"/>
+                </a:solidFill>
+                <a:latin typeface="Calibri"/>
+              </a:defRPr>
+            </a:pPr>
+            <a:r>
+              <a:t>Feasibility Analysis</a:t>
+            </a:r>
+          </a:p>
+          <a:p>
+            <a:pPr>
+              <a:spcAft>
+                <a:spcPts val="200"/>
+              </a:spcAft>
+            </a:pPr>
+            <a:r>
+              <a:rPr b="1" sz="950">
                 <a:solidFill>
                   <a:srgbClr val="102A4D"/>
                 </a:solidFill>
                 <a:latin typeface="Calibri"/>
-              </a:defRPr>
-            </a:pPr>
-            <a:r>
-              <a:t>Prototype Ready Tech Stack</a:t>
-            </a:r>
-          </a:p>
-          <a:p>
-            <a:pPr algn="ctr">
-              <a:defRPr sz="950">
+              </a:rPr>
+              <a:t>• Prototype Ready Stack: </a:t>
+            </a:r>
+            <a:r>
+              <a:rPr sz="950">
                 <a:solidFill>
                   <a:srgbClr val="212529"/>
                 </a:solidFill>
                 <a:latin typeface="Calibri"/>
-              </a:defRPr>
-            </a:pPr>
-            <a:r>
-              <a:t>Modern production-grade stack (Next.js 16 + FastAPI + PostgreSQL/SQLite) fully implemented and operational.</a:t>
-            </a:r>
-          </a:p>
-        </p:txBody>
-      </p:sp>
-      <p:sp>
-        <p:nvSpPr>
-          <p:cNvPr id="13" name="Rounded Rectangle 12"/>
+              </a:rPr>
+              <a:t>Next.js 16 + FastAPI (Python 3.12) + PostgreSQL/SQLite</a:t>
+            </a:r>
+          </a:p>
+          <a:p>
+            <a:pPr>
+              <a:spcAft>
+                <a:spcPts val="200"/>
+              </a:spcAft>
+            </a:pPr>
+            <a:r>
+              <a:rPr b="1" sz="950">
+                <a:solidFill>
+                  <a:srgbClr val="102A4D"/>
+                </a:solidFill>
+                <a:latin typeface="Calibri"/>
+              </a:rPr>
+              <a:t>• Core AICTE Features: </a:t>
+            </a:r>
+            <a:r>
+              <a:rPr sz="950">
+                <a:solidFill>
+                  <a:srgbClr val="212529"/>
+                </a:solidFill>
+                <a:latin typeface="Calibri"/>
+              </a:rPr>
+              <a:t>Intake quota monitoring, 10-point rule engine, multi-tenant RBAC</a:t>
+            </a:r>
+          </a:p>
+          <a:p>
+            <a:pPr>
+              <a:spcAft>
+                <a:spcPts val="200"/>
+              </a:spcAft>
+            </a:pPr>
+            <a:r>
+              <a:rPr b="1" sz="950">
+                <a:solidFill>
+                  <a:srgbClr val="102A4D"/>
+                </a:solidFill>
+                <a:latin typeface="Calibri"/>
+              </a:rPr>
+              <a:t>• Scalable Deployment: </a:t>
+            </a:r>
+            <a:r>
+              <a:rPr sz="950">
+                <a:solidFill>
+                  <a:srgbClr val="212529"/>
+                </a:solidFill>
+                <a:latin typeface="Calibri"/>
+              </a:rPr>
+              <a:t>Containerized Docker microservices for low-cost nationwide university rollout</a:t>
+            </a:r>
+          </a:p>
+        </p:txBody>
+      </p:sp>
+      <p:sp>
+        <p:nvSpPr>
+          <p:cNvPr id="10" name="Rounded Rectangle 9"/>
           <p:cNvSpPr/>
           <p:nvPr/>
         </p:nvSpPr>
         <p:spPr>
           <a:xfrm>
-            <a:off x="550000" y="3350000"/>
-            <a:ext cx="3500000" cy="1300000"/>
-          </a:xfrm>
-          <a:prstGeom prst="roundRect">
-            <a:avLst/>
-          </a:prstGeom>
-          <a:solidFill>
-            <a:srgbClr val="FFF3F0"/>
-          </a:solidFill>
-          <a:ln w="19050">
-            <a:solidFill>
-              <a:srgbClr val="E55039"/>
-            </a:solidFill>
-          </a:ln>
-        </p:spPr>
-        <p:style>
-          <a:lnRef idx="1">
-            <a:schemeClr val="accent1"/>
-          </a:lnRef>
-          <a:fillRef idx="3">
-            <a:schemeClr val="accent1"/>
-          </a:fillRef>
-          <a:effectRef idx="2">
-            <a:schemeClr val="accent1"/>
-          </a:effectRef>
-          <a:fontRef idx="minor">
-            <a:schemeClr val="lt1"/>
-          </a:fontRef>
-        </p:style>
-        <p:txBody>
-          <a:bodyPr rtlCol="0" anchor="ctr" wrap="square"/>
-          <a:lstStyle/>
-          <a:p>
-            <a:pPr algn="ctr">
-              <a:spcAft>
-                <a:spcPts val="400"/>
-              </a:spcAft>
-              <a:defRPr b="1" sz="1300">
-                <a:solidFill>
-                  <a:srgbClr val="102A4D"/>
-                </a:solidFill>
-                <a:latin typeface="Calibri"/>
-              </a:defRPr>
-            </a:pPr>
-            <a:r>
-              <a:t>Core AICTE Features Achieved</a:t>
-            </a:r>
-          </a:p>
-          <a:p>
-            <a:pPr algn="ctr">
-              <a:defRPr sz="950">
-                <a:solidFill>
-                  <a:srgbClr val="212529"/>
-                </a:solidFill>
-                <a:latin typeface="Calibri"/>
-              </a:defRPr>
-            </a:pPr>
-            <a:r>
-              <a:t>Intake vs actual enrolment monitoring, 10-point validation, and multi-tenant RBAC working end-to-end.</a:t>
-            </a:r>
-          </a:p>
-        </p:txBody>
-      </p:sp>
-      <p:sp>
-        <p:nvSpPr>
-          <p:cNvPr id="14" name="Rounded Rectangle 13"/>
-          <p:cNvSpPr/>
-          <p:nvPr/>
-        </p:nvSpPr>
-        <p:spPr>
-          <a:xfrm>
-            <a:off x="550000" y="4800000"/>
-            <a:ext cx="3500000" cy="1300000"/>
-          </a:xfrm>
-          <a:prstGeom prst="roundRect">
-            <a:avLst/>
-          </a:prstGeom>
-          <a:solidFill>
-            <a:srgbClr val="FFF3F0"/>
-          </a:solidFill>
-          <a:ln w="19050">
-            <a:solidFill>
-              <a:srgbClr val="E55039"/>
-            </a:solidFill>
-          </a:ln>
-        </p:spPr>
-        <p:style>
-          <a:lnRef idx="1">
-            <a:schemeClr val="accent1"/>
-          </a:lnRef>
-          <a:fillRef idx="3">
-            <a:schemeClr val="accent1"/>
-          </a:fillRef>
-          <a:effectRef idx="2">
-            <a:schemeClr val="accent1"/>
-          </a:effectRef>
-          <a:fontRef idx="minor">
-            <a:schemeClr val="lt1"/>
-          </a:fontRef>
-        </p:style>
-        <p:txBody>
-          <a:bodyPr rtlCol="0" anchor="ctr" wrap="square"/>
-          <a:lstStyle/>
-          <a:p>
-            <a:pPr algn="ctr">
-              <a:spcAft>
-                <a:spcPts val="400"/>
-              </a:spcAft>
-              <a:defRPr b="1" sz="1300">
-                <a:solidFill>
-                  <a:srgbClr val="102A4D"/>
-                </a:solidFill>
-                <a:latin typeface="Calibri"/>
-              </a:defRPr>
-            </a:pPr>
-            <a:r>
-              <a:t>Low-Cost Scalable Deployment</a:t>
-            </a:r>
-          </a:p>
-          <a:p>
-            <a:pPr algn="ctr">
-              <a:defRPr sz="950">
-                <a:solidFill>
-                  <a:srgbClr val="212529"/>
-                </a:solidFill>
-                <a:latin typeface="Calibri"/>
-              </a:defRPr>
-            </a:pPr>
-            <a:r>
-              <a:t>Containerized Docker setup with asynchronous API endpoints for low-cost nationwide university rollout.</a:t>
-            </a:r>
-          </a:p>
-        </p:txBody>
-      </p:sp>
-      <p:sp>
-        <p:nvSpPr>
-          <p:cNvPr id="15" name="Rounded Rectangle 14"/>
-          <p:cNvSpPr/>
-          <p:nvPr/>
-        </p:nvSpPr>
-        <p:spPr>
-          <a:xfrm>
-            <a:off x="4350000" y="1900000"/>
-            <a:ext cx="3500000" cy="1300000"/>
+            <a:off x="550000" y="2840000"/>
+            <a:ext cx="5100000" cy="1550000"/>
           </a:xfrm>
           <a:prstGeom prst="roundRect">
             <a:avLst/>
@@ -7296,186 +7026,106 @@
           <a:p>
             <a:pPr algn="ctr">
               <a:spcAft>
-                <a:spcPts val="400"/>
+                <a:spcPts val="300"/>
               </a:spcAft>
-              <a:defRPr b="1" sz="1300">
+              <a:defRPr b="1" sz="1250">
+                <a:solidFill>
+                  <a:srgbClr val="F39C12"/>
+                </a:solidFill>
+                <a:latin typeface="Calibri"/>
+              </a:defRPr>
+            </a:pPr>
+            <a:r>
+              <a:t>Challenges &amp; Risks</a:t>
+            </a:r>
+          </a:p>
+          <a:p>
+            <a:pPr>
+              <a:spcAft>
+                <a:spcPts val="200"/>
+              </a:spcAft>
+            </a:pPr>
+            <a:r>
+              <a:rPr b="1" sz="950">
                 <a:solidFill>
                   <a:srgbClr val="102A4D"/>
                 </a:solidFill>
                 <a:latin typeface="Calibri"/>
-              </a:defRPr>
-            </a:pPr>
-            <a:r>
-              <a:t>Incomplete Student Records</a:t>
-            </a:r>
-          </a:p>
-          <a:p>
-            <a:pPr algn="ctr">
-              <a:defRPr sz="950">
+              </a:rPr>
+              <a:t>• Incomplete Records: </a:t>
+            </a:r>
+            <a:r>
+              <a:rPr sz="950">
                 <a:solidFill>
                   <a:srgbClr val="212529"/>
                 </a:solidFill>
                 <a:latin typeface="Calibri"/>
-              </a:defRPr>
-            </a:pPr>
-            <a:r>
-              <a:t>Institutions uploading legacy or dirty data with missing roll numbers or invalid APAAR format.</a:t>
-            </a:r>
-          </a:p>
-        </p:txBody>
-      </p:sp>
-      <p:sp>
-        <p:nvSpPr>
-          <p:cNvPr id="16" name="Rounded Rectangle 15"/>
+              </a:rPr>
+              <a:t>Institutions uploading legacy dirty data with missing roll numbers</a:t>
+            </a:r>
+          </a:p>
+          <a:p>
+            <a:pPr>
+              <a:spcAft>
+                <a:spcPts val="200"/>
+              </a:spcAft>
+            </a:pPr>
+            <a:r>
+              <a:rPr b="1" sz="950">
+                <a:solidFill>
+                  <a:srgbClr val="102A4D"/>
+                </a:solidFill>
+                <a:latin typeface="Calibri"/>
+              </a:rPr>
+              <a:t>• Dual Enrolments: </a:t>
+            </a:r>
+            <a:r>
+              <a:rPr sz="950">
+                <a:solidFill>
+                  <a:srgbClr val="212529"/>
+                </a:solidFill>
+                <a:latin typeface="Calibri"/>
+              </a:rPr>
+              <a:t>Concurrent admissions claiming duplicate technical seats &amp; scholarships</a:t>
+            </a:r>
+          </a:p>
+          <a:p>
+            <a:pPr>
+              <a:spcAft>
+                <a:spcPts val="200"/>
+              </a:spcAft>
+            </a:pPr>
+            <a:r>
+              <a:rPr b="1" sz="950">
+                <a:solidFill>
+                  <a:srgbClr val="102A4D"/>
+                </a:solidFill>
+                <a:latin typeface="Calibri"/>
+              </a:rPr>
+              <a:t>• API Latency / Outage: </a:t>
+            </a:r>
+            <a:r>
+              <a:rPr sz="950">
+                <a:solidFill>
+                  <a:srgbClr val="212529"/>
+                </a:solidFill>
+                <a:latin typeface="Calibri"/>
+              </a:rPr>
+              <a:t>Rate limits or temporary downtime on third-party verification APIs</a:t>
+            </a:r>
+          </a:p>
+        </p:txBody>
+      </p:sp>
+      <p:sp>
+        <p:nvSpPr>
+          <p:cNvPr id="11" name="Rounded Rectangle 10"/>
           <p:cNvSpPr/>
           <p:nvPr/>
         </p:nvSpPr>
         <p:spPr>
           <a:xfrm>
-            <a:off x="4350000" y="3350000"/>
-            <a:ext cx="3500000" cy="1300000"/>
-          </a:xfrm>
-          <a:prstGeom prst="roundRect">
-            <a:avLst/>
-          </a:prstGeom>
-          <a:solidFill>
-            <a:srgbClr val="FEF9E7"/>
-          </a:solidFill>
-          <a:ln w="19050">
-            <a:solidFill>
-              <a:srgbClr val="F39C12"/>
-            </a:solidFill>
-          </a:ln>
-        </p:spPr>
-        <p:style>
-          <a:lnRef idx="1">
-            <a:schemeClr val="accent1"/>
-          </a:lnRef>
-          <a:fillRef idx="3">
-            <a:schemeClr val="accent1"/>
-          </a:fillRef>
-          <a:effectRef idx="2">
-            <a:schemeClr val="accent1"/>
-          </a:effectRef>
-          <a:fontRef idx="minor">
-            <a:schemeClr val="lt1"/>
-          </a:fontRef>
-        </p:style>
-        <p:txBody>
-          <a:bodyPr rtlCol="0" anchor="ctr" wrap="square"/>
-          <a:lstStyle/>
-          <a:p>
-            <a:pPr algn="ctr">
-              <a:spcAft>
-                <a:spcPts val="400"/>
-              </a:spcAft>
-              <a:defRPr b="1" sz="1300">
-                <a:solidFill>
-                  <a:srgbClr val="102A4D"/>
-                </a:solidFill>
-                <a:latin typeface="Calibri"/>
-              </a:defRPr>
-            </a:pPr>
-            <a:r>
-              <a:t>Cross-Campus Dual Enrolments</a:t>
-            </a:r>
-          </a:p>
-          <a:p>
-            <a:pPr algn="ctr">
-              <a:defRPr sz="950">
-                <a:solidFill>
-                  <a:srgbClr val="212529"/>
-                </a:solidFill>
-                <a:latin typeface="Calibri"/>
-              </a:defRPr>
-            </a:pPr>
-            <a:r>
-              <a:t>Students concurrently admitted across two institutions claiming duplicate seats and scholarships.</a:t>
-            </a:r>
-          </a:p>
-        </p:txBody>
-      </p:sp>
-      <p:sp>
-        <p:nvSpPr>
-          <p:cNvPr id="17" name="Rounded Rectangle 16"/>
-          <p:cNvSpPr/>
-          <p:nvPr/>
-        </p:nvSpPr>
-        <p:spPr>
-          <a:xfrm>
-            <a:off x="4350000" y="4800000"/>
-            <a:ext cx="3500000" cy="1300000"/>
-          </a:xfrm>
-          <a:prstGeom prst="roundRect">
-            <a:avLst/>
-          </a:prstGeom>
-          <a:solidFill>
-            <a:srgbClr val="FEF9E7"/>
-          </a:solidFill>
-          <a:ln w="19050">
-            <a:solidFill>
-              <a:srgbClr val="F39C12"/>
-            </a:solidFill>
-          </a:ln>
-        </p:spPr>
-        <p:style>
-          <a:lnRef idx="1">
-            <a:schemeClr val="accent1"/>
-          </a:lnRef>
-          <a:fillRef idx="3">
-            <a:schemeClr val="accent1"/>
-          </a:fillRef>
-          <a:effectRef idx="2">
-            <a:schemeClr val="accent1"/>
-          </a:effectRef>
-          <a:fontRef idx="minor">
-            <a:schemeClr val="lt1"/>
-          </a:fontRef>
-        </p:style>
-        <p:txBody>
-          <a:bodyPr rtlCol="0" anchor="ctr" wrap="square"/>
-          <a:lstStyle/>
-          <a:p>
-            <a:pPr algn="ctr">
-              <a:spcAft>
-                <a:spcPts val="400"/>
-              </a:spcAft>
-              <a:defRPr b="1" sz="1300">
-                <a:solidFill>
-                  <a:srgbClr val="102A4D"/>
-                </a:solidFill>
-                <a:latin typeface="Calibri"/>
-              </a:defRPr>
-            </a:pPr>
-            <a:r>
-              <a:t>Verification Service Limits</a:t>
-            </a:r>
-          </a:p>
-          <a:p>
-            <a:pPr algn="ctr">
-              <a:defRPr sz="950">
-                <a:solidFill>
-                  <a:srgbClr val="212529"/>
-                </a:solidFill>
-                <a:latin typeface="Calibri"/>
-              </a:defRPr>
-            </a:pPr>
-            <a:r>
-              <a:t>Rate limits, network latency, or unexpected downtime on official third-party APAAR/ABC APIs.</a:t>
-            </a:r>
-          </a:p>
-        </p:txBody>
-      </p:sp>
-      <p:sp>
-        <p:nvSpPr>
-          <p:cNvPr id="18" name="Rounded Rectangle 17"/>
-          <p:cNvSpPr/>
-          <p:nvPr/>
-        </p:nvSpPr>
-        <p:spPr>
-          <a:xfrm>
-            <a:off x="8150000" y="1900000"/>
-            <a:ext cx="3500000" cy="1300000"/>
+            <a:off x="550000" y="4530000"/>
+            <a:ext cx="5100000" cy="1550000"/>
           </a:xfrm>
           <a:prstGeom prst="roundRect">
             <a:avLst/>
@@ -7509,8 +7159,179 @@
           <a:p>
             <a:pPr algn="ctr">
               <a:spcAft>
-                <a:spcPts val="400"/>
+                <a:spcPts val="300"/>
               </a:spcAft>
+              <a:defRPr b="1" sz="1250">
+                <a:solidFill>
+                  <a:srgbClr val="2980B9"/>
+                </a:solidFill>
+                <a:latin typeface="Calibri"/>
+              </a:defRPr>
+            </a:pPr>
+            <a:r>
+              <a:t>Mitigation Strategies</a:t>
+            </a:r>
+          </a:p>
+          <a:p>
+            <a:pPr>
+              <a:spcAft>
+                <a:spcPts val="200"/>
+              </a:spcAft>
+            </a:pPr>
+            <a:r>
+              <a:rPr b="1" sz="950">
+                <a:solidFill>
+                  <a:srgbClr val="102A4D"/>
+                </a:solidFill>
+                <a:latin typeface="Calibri"/>
+              </a:rPr>
+              <a:t>• Automated Pre-Checks: </a:t>
+            </a:r>
+            <a:r>
+              <a:rPr sz="950">
+                <a:solidFill>
+                  <a:srgbClr val="212529"/>
+                </a:solidFill>
+                <a:latin typeface="Calibri"/>
+              </a:rPr>
+              <a:t>Immediate schema validation with human-in-the-loop correction desk</a:t>
+            </a:r>
+          </a:p>
+          <a:p>
+            <a:pPr>
+              <a:spcAft>
+                <a:spcPts val="200"/>
+              </a:spcAft>
+            </a:pPr>
+            <a:r>
+              <a:rPr b="1" sz="950">
+                <a:solidFill>
+                  <a:srgbClr val="102A4D"/>
+                </a:solidFill>
+                <a:latin typeface="Calibri"/>
+              </a:rPr>
+              <a:t>• Fuzzy / Exact Detector: </a:t>
+            </a:r>
+            <a:r>
+              <a:rPr sz="950">
+                <a:solidFill>
+                  <a:srgbClr val="212529"/>
+                </a:solidFill>
+                <a:latin typeface="Calibri"/>
+              </a:rPr>
+              <a:t>Cross-campus duplicate identification with immutable audit logs</a:t>
+            </a:r>
+          </a:p>
+          <a:p>
+            <a:pPr>
+              <a:spcAft>
+                <a:spcPts val="200"/>
+              </a:spcAft>
+            </a:pPr>
+            <a:r>
+              <a:rPr b="1" sz="950">
+                <a:solidFill>
+                  <a:srgbClr val="102A4D"/>
+                </a:solidFill>
+                <a:latin typeface="Calibri"/>
+              </a:rPr>
+              <a:t>• Simulation Sandbox: </a:t>
+            </a:r>
+            <a:r>
+              <a:rPr sz="950">
+                <a:solidFill>
+                  <a:srgbClr val="212529"/>
+                </a:solidFill>
+                <a:latin typeface="Calibri"/>
+              </a:rPr>
+              <a:t>Pluggable offline adapter enables seamless testing without external downtime</a:t>
+            </a:r>
+          </a:p>
+        </p:txBody>
+      </p:sp>
+      <p:sp>
+        <p:nvSpPr>
+          <p:cNvPr id="12" name="TextBox 11"/>
+          <p:cNvSpPr txBox="1"/>
+          <p:nvPr/>
+        </p:nvSpPr>
+        <p:spPr>
+          <a:xfrm>
+            <a:off x="6000000" y="1150000"/>
+            <a:ext cx="5600000" cy="400000"/>
+          </a:xfrm>
+          <a:prstGeom prst="rect">
+            <a:avLst/>
+          </a:prstGeom>
+          <a:noFill/>
+        </p:spPr>
+        <p:txBody>
+          <a:bodyPr wrap="none">
+            <a:spAutoFit/>
+          </a:bodyPr>
+          <a:lstStyle/>
+          <a:p>
+            <a:pPr algn="ctr">
+              <a:defRPr b="1" sz="1500">
+                <a:solidFill>
+                  <a:srgbClr val="102A4D"/>
+                </a:solidFill>
+                <a:latin typeface="Calibri"/>
+              </a:defRPr>
+            </a:pPr>
+            <a:r>
+              <a:t>PROTOTYPE SCREENSHOT</a:t>
+            </a:r>
+          </a:p>
+        </p:txBody>
+      </p:sp>
+      <p:pic>
+        <p:nvPicPr>
+          <p:cNvPr id="13" name="Picture 12" descr="prototype_audit_security_screenshot.png"/>
+          <p:cNvPicPr>
+            <a:picLocks noChangeAspect="1"/>
+          </p:cNvPicPr>
+          <p:nvPr/>
+        </p:nvPicPr>
+        <p:blipFill>
+          <a:blip r:embed="rId3"/>
+          <a:stretch>
+            <a:fillRect/>
+          </a:stretch>
+        </p:blipFill>
+        <p:spPr>
+          <a:xfrm>
+            <a:off x="6000000" y="1650000"/>
+            <a:ext cx="5600000" cy="4000000"/>
+          </a:xfrm>
+          <a:prstGeom prst="rect">
+            <a:avLst/>
+          </a:prstGeom>
+        </p:spPr>
+      </p:pic>
+      <p:sp>
+        <p:nvSpPr>
+          <p:cNvPr id="14" name="TextBox 13"/>
+          <p:cNvSpPr txBox="1"/>
+          <p:nvPr/>
+        </p:nvSpPr>
+        <p:spPr>
+          <a:xfrm>
+            <a:off x="6000000" y="5750000"/>
+            <a:ext cx="5600000" cy="450000"/>
+          </a:xfrm>
+          <a:prstGeom prst="rect">
+            <a:avLst/>
+          </a:prstGeom>
+          <a:noFill/>
+        </p:spPr>
+        <p:txBody>
+          <a:bodyPr wrap="none">
+            <a:spAutoFit/>
+          </a:bodyPr>
+          <a:lstStyle/>
+          <a:p>
+            <a:pPr algn="ctr">
               <a:defRPr b="1" sz="1300">
                 <a:solidFill>
                   <a:srgbClr val="102A4D"/>
@@ -7519,162 +7340,7 @@
               </a:defRPr>
             </a:pPr>
             <a:r>
-              <a:t>Automated Checks &amp; Corrections</a:t>
-            </a:r>
-          </a:p>
-          <a:p>
-            <a:pPr algn="ctr">
-              <a:defRPr sz="950">
-                <a:solidFill>
-                  <a:srgbClr val="212529"/>
-                </a:solidFill>
-                <a:latin typeface="Calibri"/>
-              </a:defRPr>
-            </a:pPr>
-            <a:r>
-              <a:t>Immediate schema checks on upload with human-in-the-loop correction and re-validation workflows.</a:t>
-            </a:r>
-          </a:p>
-        </p:txBody>
-      </p:sp>
-      <p:sp>
-        <p:nvSpPr>
-          <p:cNvPr id="19" name="Rounded Rectangle 18"/>
-          <p:cNvSpPr/>
-          <p:nvPr/>
-        </p:nvSpPr>
-        <p:spPr>
-          <a:xfrm>
-            <a:off x="8150000" y="3350000"/>
-            <a:ext cx="3500000" cy="1300000"/>
-          </a:xfrm>
-          <a:prstGeom prst="roundRect">
-            <a:avLst/>
-          </a:prstGeom>
-          <a:solidFill>
-            <a:srgbClr val="EBF5FB"/>
-          </a:solidFill>
-          <a:ln w="19050">
-            <a:solidFill>
-              <a:srgbClr val="2980B9"/>
-            </a:solidFill>
-          </a:ln>
-        </p:spPr>
-        <p:style>
-          <a:lnRef idx="1">
-            <a:schemeClr val="accent1"/>
-          </a:lnRef>
-          <a:fillRef idx="3">
-            <a:schemeClr val="accent1"/>
-          </a:fillRef>
-          <a:effectRef idx="2">
-            <a:schemeClr val="accent1"/>
-          </a:effectRef>
-          <a:fontRef idx="minor">
-            <a:schemeClr val="lt1"/>
-          </a:fontRef>
-        </p:style>
-        <p:txBody>
-          <a:bodyPr rtlCol="0" anchor="ctr" wrap="square"/>
-          <a:lstStyle/>
-          <a:p>
-            <a:pPr algn="ctr">
-              <a:spcAft>
-                <a:spcPts val="400"/>
-              </a:spcAft>
-              <a:defRPr b="1" sz="1300">
-                <a:solidFill>
-                  <a:srgbClr val="102A4D"/>
-                </a:solidFill>
-                <a:latin typeface="Calibri"/>
-              </a:defRPr>
-            </a:pPr>
-            <a:r>
-              <a:t>Fuzzy &amp; Rule-Based Detector</a:t>
-            </a:r>
-          </a:p>
-          <a:p>
-            <a:pPr algn="ctr">
-              <a:defRPr sz="950">
-                <a:solidFill>
-                  <a:srgbClr val="212529"/>
-                </a:solidFill>
-                <a:latin typeface="Calibri"/>
-              </a:defRPr>
-            </a:pPr>
-            <a:r>
-              <a:t>Similarity and exact-match algorithms flag dual enrolments with resolution audit logs.</a:t>
-            </a:r>
-          </a:p>
-        </p:txBody>
-      </p:sp>
-      <p:sp>
-        <p:nvSpPr>
-          <p:cNvPr id="20" name="Rounded Rectangle 19"/>
-          <p:cNvSpPr/>
-          <p:nvPr/>
-        </p:nvSpPr>
-        <p:spPr>
-          <a:xfrm>
-            <a:off x="8150000" y="4800000"/>
-            <a:ext cx="3500000" cy="1300000"/>
-          </a:xfrm>
-          <a:prstGeom prst="roundRect">
-            <a:avLst/>
-          </a:prstGeom>
-          <a:solidFill>
-            <a:srgbClr val="EBF5FB"/>
-          </a:solidFill>
-          <a:ln w="19050">
-            <a:solidFill>
-              <a:srgbClr val="2980B9"/>
-            </a:solidFill>
-          </a:ln>
-        </p:spPr>
-        <p:style>
-          <a:lnRef idx="1">
-            <a:schemeClr val="accent1"/>
-          </a:lnRef>
-          <a:fillRef idx="3">
-            <a:schemeClr val="accent1"/>
-          </a:fillRef>
-          <a:effectRef idx="2">
-            <a:schemeClr val="accent1"/>
-          </a:effectRef>
-          <a:fontRef idx="minor">
-            <a:schemeClr val="lt1"/>
-          </a:fontRef>
-        </p:style>
-        <p:txBody>
-          <a:bodyPr rtlCol="0" anchor="ctr" wrap="square"/>
-          <a:lstStyle/>
-          <a:p>
-            <a:pPr algn="ctr">
-              <a:spcAft>
-                <a:spcPts val="400"/>
-              </a:spcAft>
-              <a:defRPr b="1" sz="1300">
-                <a:solidFill>
-                  <a:srgbClr val="102A4D"/>
-                </a:solidFill>
-                <a:latin typeface="Calibri"/>
-              </a:defRPr>
-            </a:pPr>
-            <a:r>
-              <a:t>Pluggable Dual-Adapter Design</a:t>
-            </a:r>
-          </a:p>
-          <a:p>
-            <a:pPr algn="ctr">
-              <a:defRPr sz="950">
-                <a:solidFill>
-                  <a:srgbClr val="212529"/>
-                </a:solidFill>
-                <a:latin typeface="Calibri"/>
-              </a:defRPr>
-            </a:pPr>
-            <a:r>
-              <a:t>Built-in simulation sandbox allows seamless offline testing with zero external API downtime.</a:t>
+              <a:t>Tamper-Evident SHA-256 Audit Ledger &amp; Dispute Correction Desk</a:t>
             </a:r>
           </a:p>
         </p:txBody>
@@ -7959,8 +7625,8 @@
         </p:nvSpPr>
         <p:spPr>
           <a:xfrm>
-            <a:off x="550000" y="1250000"/>
-            <a:ext cx="3600000" cy="1550000"/>
+            <a:off x="550000" y="1150000"/>
+            <a:ext cx="5100000" cy="820000"/>
           </a:xfrm>
           <a:prstGeom prst="roundRect">
             <a:avLst/>
@@ -8004,8 +7670,8 @@
         </p:nvSpPr>
         <p:spPr>
           <a:xfrm>
-            <a:off x="670000" y="1350000"/>
-            <a:ext cx="800000" cy="1350000"/>
+            <a:off x="630000" y="1210000"/>
+            <a:ext cx="600000" cy="700000"/>
           </a:xfrm>
           <a:prstGeom prst="rect">
             <a:avLst/>
@@ -8019,7 +7685,7 @@
           <a:lstStyle/>
           <a:p>
             <a:pPr algn="ctr">
-              <a:defRPr b="1" sz="3600">
+              <a:defRPr b="1" sz="2600">
                 <a:solidFill>
                   <a:srgbClr val="E65100"/>
                 </a:solidFill>
@@ -8040,8 +7706,8 @@
         </p:nvSpPr>
         <p:spPr>
           <a:xfrm>
-            <a:off x="1500000" y="1370000"/>
-            <a:ext cx="2550000" cy="1310000"/>
+            <a:off x="1270000" y="1210000"/>
+            <a:ext cx="4300000" cy="700000"/>
           </a:xfrm>
           <a:prstGeom prst="rect">
             <a:avLst/>
@@ -8056,9 +7722,9 @@
           <a:p>
             <a:pPr>
               <a:spcAft>
-                <a:spcPts val="400"/>
+                <a:spcPts val="200"/>
               </a:spcAft>
-              <a:defRPr b="1" sz="1300">
+              <a:defRPr b="1" sz="1150">
                 <a:solidFill>
                   <a:srgbClr val="102A4D"/>
                 </a:solidFill>
@@ -8071,7 +7737,7 @@
           </a:p>
           <a:p>
             <a:pPr>
-              <a:defRPr sz="1000">
+              <a:defRPr sz="950">
                 <a:solidFill>
                   <a:srgbClr val="212529"/>
                 </a:solidFill>
@@ -8079,7 +7745,7 @@
               </a:defRPr>
             </a:pPr>
             <a:r>
-              <a:t>Real-time intake vs enrolment monitoring eliminates unauthorized seat over-allocation and ghost enrolments across technical campuses.</a:t>
+              <a:t>Real-time quota monitoring eliminates unauthorized seat over-allocation and ghost seats.</a:t>
             </a:r>
           </a:p>
         </p:txBody>
@@ -8092,8 +7758,8 @@
         </p:nvSpPr>
         <p:spPr>
           <a:xfrm>
-            <a:off x="550000" y="3000000"/>
-            <a:ext cx="3600000" cy="1550000"/>
+            <a:off x="550000" y="2050000"/>
+            <a:ext cx="5100000" cy="820000"/>
           </a:xfrm>
           <a:prstGeom prst="roundRect">
             <a:avLst/>
@@ -8137,8 +7803,8 @@
         </p:nvSpPr>
         <p:spPr>
           <a:xfrm>
-            <a:off x="670000" y="3100000"/>
-            <a:ext cx="800000" cy="1350000"/>
+            <a:off x="630000" y="2110000"/>
+            <a:ext cx="600000" cy="700000"/>
           </a:xfrm>
           <a:prstGeom prst="rect">
             <a:avLst/>
@@ -8152,7 +7818,7 @@
           <a:lstStyle/>
           <a:p>
             <a:pPr algn="ctr">
-              <a:defRPr b="1" sz="3600">
+              <a:defRPr b="1" sz="2600">
                 <a:solidFill>
                   <a:srgbClr val="E65100"/>
                 </a:solidFill>
@@ -8173,8 +7839,8 @@
         </p:nvSpPr>
         <p:spPr>
           <a:xfrm>
-            <a:off x="1500000" y="3120000"/>
-            <a:ext cx="2550000" cy="1310000"/>
+            <a:off x="1270000" y="2110000"/>
+            <a:ext cx="4300000" cy="700000"/>
           </a:xfrm>
           <a:prstGeom prst="rect">
             <a:avLst/>
@@ -8189,9 +7855,9 @@
           <a:p>
             <a:pPr>
               <a:spcAft>
-                <a:spcPts val="400"/>
+                <a:spcPts val="200"/>
               </a:spcAft>
-              <a:defRPr b="1" sz="1300">
+              <a:defRPr b="1" sz="1150">
                 <a:solidFill>
                   <a:srgbClr val="102A4D"/>
                 </a:solidFill>
@@ -8204,7 +7870,7 @@
           </a:p>
           <a:p>
             <a:pPr>
-              <a:defRPr sz="1000">
+              <a:defRPr sz="950">
                 <a:solidFill>
                   <a:srgbClr val="212529"/>
                 </a:solidFill>
@@ -8212,7 +7878,7 @@
               </a:defRPr>
             </a:pPr>
             <a:r>
-              <a:t>Automated cross-institutional checks prevent concurrent admissions and fraudulent duplicate scholarship claims.</a:t>
+              <a:t>Cross-campus checks prevent concurrent admissions and duplicate scholarship claims.</a:t>
             </a:r>
           </a:p>
         </p:txBody>
@@ -8225,8 +7891,8 @@
         </p:nvSpPr>
         <p:spPr>
           <a:xfrm>
-            <a:off x="4350000" y="2100000"/>
-            <a:ext cx="3600000" cy="1550000"/>
+            <a:off x="550000" y="2950000"/>
+            <a:ext cx="5100000" cy="820000"/>
           </a:xfrm>
           <a:prstGeom prst="roundRect">
             <a:avLst/>
@@ -8270,8 +7936,8 @@
         </p:nvSpPr>
         <p:spPr>
           <a:xfrm>
-            <a:off x="4470000" y="2200000"/>
-            <a:ext cx="800000" cy="1350000"/>
+            <a:off x="630000" y="3010000"/>
+            <a:ext cx="600000" cy="700000"/>
           </a:xfrm>
           <a:prstGeom prst="rect">
             <a:avLst/>
@@ -8285,7 +7951,7 @@
           <a:lstStyle/>
           <a:p>
             <a:pPr algn="ctr">
-              <a:defRPr b="1" sz="3600">
+              <a:defRPr b="1" sz="2600">
                 <a:solidFill>
                   <a:srgbClr val="2980B9"/>
                 </a:solidFill>
@@ -8306,8 +7972,8 @@
         </p:nvSpPr>
         <p:spPr>
           <a:xfrm>
-            <a:off x="5300000" y="2220000"/>
-            <a:ext cx="2550000" cy="1310000"/>
+            <a:off x="1270000" y="3010000"/>
+            <a:ext cx="4300000" cy="700000"/>
           </a:xfrm>
           <a:prstGeom prst="rect">
             <a:avLst/>
@@ -8322,9 +7988,9 @@
           <a:p>
             <a:pPr>
               <a:spcAft>
-                <a:spcPts val="400"/>
+                <a:spcPts val="200"/>
               </a:spcAft>
-              <a:defRPr b="1" sz="1300">
+              <a:defRPr b="1" sz="1150">
                 <a:solidFill>
                   <a:srgbClr val="102A4D"/>
                 </a:solidFill>
@@ -8337,7 +8003,7 @@
           </a:p>
           <a:p>
             <a:pPr>
-              <a:defRPr sz="1000">
+              <a:defRPr sz="950">
                 <a:solidFill>
                   <a:srgbClr val="212529"/>
                 </a:solidFill>
@@ -8345,7 +8011,7 @@
               </a:defRPr>
             </a:pPr>
             <a:r>
-              <a:t>Cryptographic zero-knowledge verification prevents credential tampering, fake degrees, and falsified academic records.</a:t>
+              <a:t>Cryptographic zero-knowledge verification prevents credential tampering &amp; fake records.</a:t>
             </a:r>
           </a:p>
         </p:txBody>
@@ -8358,8 +8024,8 @@
         </p:nvSpPr>
         <p:spPr>
           <a:xfrm>
-            <a:off x="8150000" y="1250000"/>
-            <a:ext cx="3600000" cy="1550000"/>
+            <a:off x="550000" y="3850000"/>
+            <a:ext cx="5100000" cy="820000"/>
           </a:xfrm>
           <a:prstGeom prst="roundRect">
             <a:avLst/>
@@ -8403,8 +8069,8 @@
         </p:nvSpPr>
         <p:spPr>
           <a:xfrm>
-            <a:off x="8270000" y="1350000"/>
-            <a:ext cx="800000" cy="1350000"/>
+            <a:off x="630000" y="3910000"/>
+            <a:ext cx="600000" cy="700000"/>
           </a:xfrm>
           <a:prstGeom prst="rect">
             <a:avLst/>
@@ -8418,7 +8084,7 @@
           <a:lstStyle/>
           <a:p>
             <a:pPr algn="ctr">
-              <a:defRPr b="1" sz="3600">
+              <a:defRPr b="1" sz="2600">
                 <a:solidFill>
                   <a:srgbClr val="2980B9"/>
                 </a:solidFill>
@@ -8439,8 +8105,8 @@
         </p:nvSpPr>
         <p:spPr>
           <a:xfrm>
-            <a:off x="9100000" y="1370000"/>
-            <a:ext cx="2550000" cy="1310000"/>
+            <a:off x="1270000" y="3910000"/>
+            <a:ext cx="4300000" cy="700000"/>
           </a:xfrm>
           <a:prstGeom prst="rect">
             <a:avLst/>
@@ -8455,9 +8121,9 @@
           <a:p>
             <a:pPr>
               <a:spcAft>
-                <a:spcPts val="400"/>
+                <a:spcPts val="200"/>
               </a:spcAft>
-              <a:defRPr b="1" sz="1300">
+              <a:defRPr b="1" sz="1150">
                 <a:solidFill>
                   <a:srgbClr val="102A4D"/>
                 </a:solidFill>
@@ -8470,7 +8136,7 @@
           </a:p>
           <a:p>
             <a:pPr>
-              <a:defRPr sz="1000">
+              <a:defRPr sz="950">
                 <a:solidFill>
                   <a:srgbClr val="212529"/>
                 </a:solidFill>
@@ -8478,7 +8144,7 @@
               </a:defRPr>
             </a:pPr>
             <a:r>
-              <a:t>Standardized bulk upload and 10-point automated checks reduce manual reporting workload and inspection backlogs by 80%.</a:t>
+              <a:t>Automated 10-point rule engine reduces manual inspection workload and backlogs by 80%.</a:t>
             </a:r>
           </a:p>
         </p:txBody>
@@ -8491,8 +8157,8 @@
         </p:nvSpPr>
         <p:spPr>
           <a:xfrm>
-            <a:off x="8150000" y="3000000"/>
-            <a:ext cx="3600000" cy="1550000"/>
+            <a:off x="550000" y="4750000"/>
+            <a:ext cx="5100000" cy="820000"/>
           </a:xfrm>
           <a:prstGeom prst="roundRect">
             <a:avLst/>
@@ -8536,8 +8202,8 @@
         </p:nvSpPr>
         <p:spPr>
           <a:xfrm>
-            <a:off x="8270000" y="3100000"/>
-            <a:ext cx="800000" cy="1350000"/>
+            <a:off x="630000" y="4810000"/>
+            <a:ext cx="600000" cy="700000"/>
           </a:xfrm>
           <a:prstGeom prst="rect">
             <a:avLst/>
@@ -8551,7 +8217,7 @@
           <a:lstStyle/>
           <a:p>
             <a:pPr algn="ctr">
-              <a:defRPr b="1" sz="3600">
+              <a:defRPr b="1" sz="2600">
                 <a:solidFill>
                   <a:srgbClr val="2980B9"/>
                 </a:solidFill>
@@ -8572,8 +8238,8 @@
         </p:nvSpPr>
         <p:spPr>
           <a:xfrm>
-            <a:off x="9100000" y="3120000"/>
-            <a:ext cx="2550000" cy="1310000"/>
+            <a:off x="1270000" y="4810000"/>
+            <a:ext cx="4300000" cy="700000"/>
           </a:xfrm>
           <a:prstGeom prst="rect">
             <a:avLst/>
@@ -8588,9 +8254,9 @@
           <a:p>
             <a:pPr>
               <a:spcAft>
-                <a:spcPts val="400"/>
+                <a:spcPts val="200"/>
               </a:spcAft>
-              <a:defRPr b="1" sz="1300">
+              <a:defRPr b="1" sz="1150">
                 <a:solidFill>
                   <a:srgbClr val="102A4D"/>
                 </a:solidFill>
@@ -8603,7 +8269,7 @@
           </a:p>
           <a:p>
             <a:pPr>
-              <a:defRPr sz="1000">
+              <a:defRPr sz="950">
                 <a:solidFill>
                   <a:srgbClr val="212529"/>
                 </a:solidFill>
@@ -8611,21 +8277,117 @@
               </a:defRPr>
             </a:pPr>
             <a:r>
-              <a:t>Privacy-by-design architecture strictly adheres to DPDP Act 2023, ready for nationwide rollout across all AICTE universities.</a:t>
-            </a:r>
-          </a:p>
-        </p:txBody>
-      </p:sp>
-      <p:sp>
-        <p:nvSpPr>
-          <p:cNvPr id="24" name="Rounded Rectangle 23"/>
+              <a:t>Privacy-by-design architecture adheres to DPDP Act 2023 for nationwide university rollout.</a:t>
+            </a:r>
+          </a:p>
+        </p:txBody>
+      </p:sp>
+      <p:sp>
+        <p:nvSpPr>
+          <p:cNvPr id="24" name="TextBox 23"/>
+          <p:cNvSpPr txBox="1"/>
+          <p:nvPr/>
+        </p:nvSpPr>
+        <p:spPr>
+          <a:xfrm>
+            <a:off x="6000000" y="1150000"/>
+            <a:ext cx="5600000" cy="400000"/>
+          </a:xfrm>
+          <a:prstGeom prst="rect">
+            <a:avLst/>
+          </a:prstGeom>
+          <a:noFill/>
+        </p:spPr>
+        <p:txBody>
+          <a:bodyPr wrap="none">
+            <a:spAutoFit/>
+          </a:bodyPr>
+          <a:lstStyle/>
+          <a:p>
+            <a:pPr algn="ctr">
+              <a:defRPr b="1" sz="1500">
+                <a:solidFill>
+                  <a:srgbClr val="102A4D"/>
+                </a:solidFill>
+                <a:latin typeface="Calibri"/>
+              </a:defRPr>
+            </a:pPr>
+            <a:r>
+              <a:t>PROTOTYPE SCREENSHOT</a:t>
+            </a:r>
+          </a:p>
+        </p:txBody>
+      </p:sp>
+      <p:pic>
+        <p:nvPicPr>
+          <p:cNvPr id="25" name="Picture 24" descr="prototype_impact_analytics_screenshot.png"/>
+          <p:cNvPicPr>
+            <a:picLocks noChangeAspect="1"/>
+          </p:cNvPicPr>
+          <p:nvPr/>
+        </p:nvPicPr>
+        <p:blipFill>
+          <a:blip r:embed="rId3"/>
+          <a:stretch>
+            <a:fillRect/>
+          </a:stretch>
+        </p:blipFill>
+        <p:spPr>
+          <a:xfrm>
+            <a:off x="6000000" y="1650000"/>
+            <a:ext cx="5600000" cy="3700000"/>
+          </a:xfrm>
+          <a:prstGeom prst="rect">
+            <a:avLst/>
+          </a:prstGeom>
+        </p:spPr>
+      </p:pic>
+      <p:sp>
+        <p:nvSpPr>
+          <p:cNvPr id="26" name="TextBox 25"/>
+          <p:cNvSpPr txBox="1"/>
+          <p:nvPr/>
+        </p:nvSpPr>
+        <p:spPr>
+          <a:xfrm>
+            <a:off x="6000000" y="5400000"/>
+            <a:ext cx="5600000" cy="300000"/>
+          </a:xfrm>
+          <a:prstGeom prst="rect">
+            <a:avLst/>
+          </a:prstGeom>
+          <a:noFill/>
+        </p:spPr>
+        <p:txBody>
+          <a:bodyPr wrap="none">
+            <a:spAutoFit/>
+          </a:bodyPr>
+          <a:lstStyle/>
+          <a:p>
+            <a:pPr algn="ctr">
+              <a:defRPr b="1" sz="1200">
+                <a:solidFill>
+                  <a:srgbClr val="102A4D"/>
+                </a:solidFill>
+                <a:latin typeface="Calibri"/>
+              </a:defRPr>
+            </a:pPr>
+            <a:r>
+              <a:t>AICTE National Impact Analytics &amp; Quota Compliance Dashboard</a:t>
+            </a:r>
+          </a:p>
+        </p:txBody>
+      </p:sp>
+      <p:sp>
+        <p:nvSpPr>
+          <p:cNvPr id="27" name="Rounded Rectangle 26"/>
           <p:cNvSpPr/>
           <p:nvPr/>
         </p:nvSpPr>
         <p:spPr>
           <a:xfrm>
-            <a:off x="550000" y="4800000"/>
-            <a:ext cx="11200000" cy="1300000"/>
+            <a:off x="550000" y="5780000"/>
+            <a:ext cx="11050000" cy="850000"/>
           </a:xfrm>
           <a:prstGeom prst="roundRect">
             <a:avLst/>
@@ -8633,7 +8395,7 @@
           <a:solidFill>
             <a:srgbClr val="FFF8F0"/>
           </a:solidFill>
-          <a:ln w="25400">
+          <a:ln w="19050">
             <a:solidFill>
               <a:srgbClr val="E65100"/>
             </a:solidFill>
@@ -8659,27 +8421,11 @@
           <a:p>
             <a:pPr algn="ctr">
               <a:spcAft>
-                <a:spcPts val="400"/>
+                <a:spcPts val="200"/>
               </a:spcAft>
-              <a:defRPr b="1" sz="1300">
-                <a:solidFill>
-                  <a:srgbClr val="A93226"/>
-                </a:solidFill>
-                <a:latin typeface="Calibri"/>
-              </a:defRPr>
-            </a:pPr>
-            <a:r>
-              <a:t>🎥 WORKING PROTOTYPE DEMONSTRATION &amp; REPOSITORY LINKS</a:t>
-            </a:r>
-          </a:p>
-          <a:p>
-            <a:pPr algn="ctr">
-              <a:spcAft>
-                <a:spcPts val="400"/>
-              </a:spcAft>
-            </a:pPr>
-            <a:r>
-              <a:rPr b="1" sz="1150">
+            </a:pPr>
+            <a:r>
+              <a:rPr b="1" sz="1100">
                 <a:solidFill>
                   <a:srgbClr val="A93226"/>
                 </a:solidFill>
@@ -8688,12 +8434,12 @@
               <a:t>▶ YouTube Prototype Video: </a:t>
             </a:r>
             <a:r>
-              <a:rPr b="1" sz="1150" u="sng">
+              <a:rPr b="1" sz="1100" u="sng">
                 <a:solidFill>
                   <a:srgbClr val="0066CC"/>
                 </a:solidFill>
                 <a:latin typeface="Calibri"/>
-                <a:hlinkClick r:id="rId3"/>
+                <a:hlinkClick r:id="rId4"/>
               </a:rPr>
               <a:t>https://youtu.be/rEz9BszbQnQ?si=c1oF4zL5QWqgU2EB</a:t>
             </a:r>
@@ -8701,7 +8447,7 @@
           <a:p>
             <a:pPr algn="ctr"/>
             <a:r>
-              <a:rPr b="1" sz="1150">
+              <a:rPr b="1" sz="1100">
                 <a:solidFill>
                   <a:srgbClr val="102A4D"/>
                 </a:solidFill>
@@ -8710,12 +8456,12 @@
               <a:t>▶ GitHub Source Repository: </a:t>
             </a:r>
             <a:r>
-              <a:rPr b="1" sz="1150" u="sng">
+              <a:rPr b="1" sz="1100" u="sng">
                 <a:solidFill>
                   <a:srgbClr val="0066CC"/>
                 </a:solidFill>
                 <a:latin typeface="Calibri"/>
-                <a:hlinkClick r:id="rId4"/>
+                <a:hlinkClick r:id="rId5"/>
               </a:rPr>
               <a:t>https://github.com/SDP-001/SIH.git</a:t>
             </a:r>

</xml_diff>